<commit_message>
fix(core): blend a:alpha on pattern background colours onto white
extractBackgroundPattern still ignored alpha on a pattern fill's fgClr
and bgClr after the solid-fill fix for issue #288. Both colours are now
composited onto white the same way, so the tiled pattern the shared
renderer builds from them matches PowerPoint. Layout and master pattern
fills only surface through the already-fixed flat-colour fallback.

Adds parser tests for the pattern branch, a load-save-reload test that
keeps the pattern's a:alpha, a second pattern slide in the background
alpha e2e fixture and a matching framework-neutral assertion.

Co-Authored-By: Claude Fable 5.1 <noreply@anthropic.com>
Claude-Session: https://claude.ai/code/session_01KwZTcKpUV3kiFTQvuZtREU
</commit_message>
<xml_diff>
--- a/viewers/pptx/e2e/fixtures/background-alpha.pptx
+++ b/viewers/pptx/e2e/fixtures/background-alpha.pptx
@@ -6,6 +6,7 @@
   </p:sldMasterIdLst>
   <p:sldIdLst>
     <p:sldId id="256" r:id="rId2"/>
+    <p:sldId id="257" r:id="rId3"/>
   </p:sldIdLst>
   <p:sldSz cx="9144000" cy="5143500"/>
   <p:notesSz cx="5143500" cy="9144000"/>
@@ -99,6 +100,65 @@
             <a:r>
               <a:rPr lang="en-US"/>
               <a:t>Background alpha marker</a:t>
+            </a:r>
+          </a:p>
+        </p:txBody>
+      </p:sp>
+    </p:spTree>
+  </p:cSld>
+  <p:clrMapOvr>
+    <a:masterClrMapping/>
+  </p:clrMapOvr>
+</p:sld>
+</file>
+
+<file path=ppt/slides/slide2.xml><?xml version="1.0" encoding="utf-8"?>
+<p:sld xmlns:a="http://schemas.openxmlformats.org/drawingml/2006/main" xmlns:r="http://schemas.openxmlformats.org/officeDocument/2006/relationships" xmlns:p="http://schemas.openxmlformats.org/presentationml/2006/main">
+  <p:cSld>
+    <p:bg>
+      <p:bgPr>
+        <a:pattFill prst="pct50">
+          <a:fgClr>
+            <a:srgbClr val="CEE0F3">
+              <a:alpha val="43211"/>
+            </a:srgbClr>
+          </a:fgClr>
+          <a:bgClr>
+            <a:srgbClr val="FFFFFF"/>
+          </a:bgClr>
+        </a:pattFill>
+        <a:effectLst/>
+      </p:bgPr>
+    </p:bg>
+    <p:spTree>
+      <p:nvGrpSpPr>
+        <p:cNvPr id="1" name=""/>
+        <p:cNvGrpSpPr/>
+        <p:nvPr/>
+      </p:nvGrpSpPr>
+      <p:grpSpPr/>
+      <p:sp>
+        <p:nvSpPr>
+          <p:cNvPr id="2" name="Marker"/>
+          <p:cNvSpPr txBox="1"/>
+          <p:nvPr/>
+        </p:nvSpPr>
+        <p:spPr>
+          <a:xfrm>
+            <a:off x="508000" y="508000"/>
+            <a:ext cx="3810000" cy="508000"/>
+          </a:xfrm>
+          <a:prstGeom prst="rect">
+            <a:avLst/>
+          </a:prstGeom>
+        </p:spPr>
+        <p:txBody>
+          <a:bodyPr/>
+          <a:lstStyle/>
+          <a:p>
+            <a:r>
+              <a:rPr lang="en-US"/>
+              <a:t>Pattern background alpha marker</a:t>
             </a:r>
           </a:p>
         </p:txBody>

</xml_diff>